<commit_message>
Publish course website (built from the course calendar)
</commit_message>
<xml_diff>
--- a/slides/Module-6-Video-3-First-Degree-Price-Discrimination.pptx
+++ b/slides/Module-6-Video-3-First-Degree-Price-Discrimination.pptx
@@ -212,7 +212,7 @@
           <a:p>
             <a:fld id="{1063EF34-BBF4-4EE4-A8C7-B7C7750069CA}" type="datetimeFigureOut">
               <a:rPr lang="en-US" smtClean="0"/>
-              <a:t>9/23/2026</a:t>
+              <a:t>9/24/2026</a:t>
             </a:fld>
             <a:endParaRPr lang="en-US"/>
           </a:p>
@@ -793,7 +793,7 @@
           <a:p>
             <a:fld id="{5BCAD085-E8A6-8845-BD4E-CB4CCA059FC4}" type="datetimeFigureOut">
               <a:rPr lang="en-US" smtClean="0"/>
-              <a:t>9/23/2026</a:t>
+              <a:t>9/24/2026</a:t>
             </a:fld>
             <a:endParaRPr lang="en-US"/>
           </a:p>
@@ -1004,7 +1004,7 @@
           <a:p>
             <a:fld id="{5BCAD085-E8A6-8845-BD4E-CB4CCA059FC4}" type="datetimeFigureOut">
               <a:rPr lang="en-US" smtClean="0"/>
-              <a:t>9/23/2026</a:t>
+              <a:t>9/24/2026</a:t>
             </a:fld>
             <a:endParaRPr lang="en-US"/>
           </a:p>
@@ -7939,90 +7939,22 @@
               <a:rPr lang="en-US" dirty="0"/>
               <a:t>true MPV?</a:t>
             </a:r>
+          </a:p>
+          <a:p>
+            <a:pPr algn="l"/>
+            <a:r>
+              <a:rPr lang="en-US" dirty="0">
+                <a:latin typeface="Calibri"/>
+                <a:sym typeface="Wingdings" panose="05000000000000000000" pitchFamily="2" charset="2"/>
+              </a:rPr>
+              <a:t> In-class discussion</a:t>
+            </a:r>
             <a:endParaRPr dirty="0">
               <a:latin typeface="Calibri"/>
             </a:endParaRPr>
           </a:p>
         </p:txBody>
       </p:sp>
-      <p:grpSp>
-        <p:nvGrpSpPr>
-          <p:cNvPr id="35" name="Group 34">
-            <a:extLst>
-              <a:ext uri="{FF2B5EF4-FFF2-40B4-BE49-F238E27FC236}">
-                <a16:creationId xmlns:a16="http://schemas.microsoft.com/office/drawing/2014/main" id="{EF9D6DF7-B6CA-608F-7245-FE709435CB94}"/>
-              </a:ext>
-            </a:extLst>
-          </p:cNvPr>
-          <p:cNvGrpSpPr/>
-          <p:nvPr/>
-        </p:nvGrpSpPr>
-        <p:grpSpPr>
-          <a:xfrm>
-            <a:off x="7833074" y="3309242"/>
-            <a:ext cx="3922776" cy="3119688"/>
-            <a:chOff x="7833074" y="3309242"/>
-            <a:chExt cx="3922776" cy="3119688"/>
-          </a:xfrm>
-        </p:grpSpPr>
-        <p:pic>
-          <p:nvPicPr>
-            <p:cNvPr id="29" name="Picture 28" descr="NV_s21_bmw_price.png"/>
-            <p:cNvPicPr>
-              <a:picLocks noChangeAspect="1"/>
-            </p:cNvPicPr>
-            <p:nvPr/>
-          </p:nvPicPr>
-          <p:blipFill>
-            <a:blip r:embed="rId3"/>
-            <a:stretch>
-              <a:fillRect/>
-            </a:stretch>
-          </p:blipFill>
-          <p:spPr>
-            <a:xfrm>
-              <a:off x="7833074" y="3309242"/>
-              <a:ext cx="3922776" cy="3119688"/>
-            </a:xfrm>
-            <a:prstGeom prst="roundRect">
-              <a:avLst>
-                <a:gd name="adj" fmla="val 8000"/>
-              </a:avLst>
-            </a:prstGeom>
-            <a:effectLst>
-              <a:outerShdw blurRad="50800" dist="38100" dir="2700000" algn="tl" rotWithShape="0">
-                <a:srgbClr val="000000">
-                  <a:alpha val="50000"/>
-                </a:srgbClr>
-              </a:outerShdw>
-            </a:effectLst>
-          </p:spPr>
-        </p:pic>
-        <p:pic>
-          <p:nvPicPr>
-            <p:cNvPr id="30" name="Picture 29" descr="NV_s21_bmw_logo.png"/>
-            <p:cNvPicPr>
-              <a:picLocks noChangeAspect="1"/>
-            </p:cNvPicPr>
-            <p:nvPr/>
-          </p:nvPicPr>
-          <p:blipFill>
-            <a:blip r:embed="rId4"/>
-            <a:stretch>
-              <a:fillRect/>
-            </a:stretch>
-          </p:blipFill>
-          <p:spPr>
-            <a:xfrm>
-              <a:off x="10012680" y="5769864"/>
-              <a:ext cx="1545336" cy="550035"/>
-            </a:xfrm>
-            <a:prstGeom prst="rect">
-              <a:avLst/>
-            </a:prstGeom>
-          </p:spPr>
-        </p:pic>
-      </p:grpSp>
       <p:sp>
         <p:nvSpPr>
           <p:cNvPr id="31" name="Rectangle 30"/>
@@ -8775,39 +8707,25 @@
                                   </p:childTnLst>
                                 </p:cTn>
                               </p:par>
-                            </p:childTnLst>
-                          </p:cTn>
-                        </p:par>
-                      </p:childTnLst>
-                    </p:cTn>
-                  </p:par>
-                  <p:par>
-                    <p:cTn id="54" fill="hold">
-                      <p:stCondLst>
-                        <p:cond delay="indefinite"/>
-                      </p:stCondLst>
-                      <p:childTnLst>
-                        <p:par>
-                          <p:cTn id="55" fill="hold">
-                            <p:stCondLst>
-                              <p:cond delay="0"/>
-                            </p:stCondLst>
-                            <p:childTnLst>
                               <p:par>
-                                <p:cTn id="56" presetID="1" presetClass="entr" presetSubtype="0" fill="hold" nodeType="clickEffect">
+                                <p:cTn id="54" presetID="10" presetClass="entr" presetSubtype="0" fill="hold" nodeType="withEffect">
                                   <p:stCondLst>
                                     <p:cond delay="0"/>
                                   </p:stCondLst>
                                   <p:childTnLst>
                                     <p:set>
                                       <p:cBhvr>
-                                        <p:cTn id="57" dur="1" fill="hold">
+                                        <p:cTn id="55" dur="1" fill="hold">
                                           <p:stCondLst>
                                             <p:cond delay="0"/>
                                           </p:stCondLst>
                                         </p:cTn>
                                         <p:tgtEl>
-                                          <p:spTgt spid="35"/>
+                                          <p:spTgt spid="28">
+                                            <p:txEl>
+                                              <p:pRg st="2" end="2"/>
+                                            </p:txEl>
+                                          </p:spTgt>
                                         </p:tgtEl>
                                         <p:attrNameLst>
                                           <p:attrName>style.visibility</p:attrName>
@@ -8817,6 +8735,18 @@
                                         <p:strVal val="visible"/>
                                       </p:to>
                                     </p:set>
+                                    <p:animEffect transition="in" filter="fade">
+                                      <p:cBhvr>
+                                        <p:cTn id="56" dur="500"/>
+                                        <p:tgtEl>
+                                          <p:spTgt spid="28">
+                                            <p:txEl>
+                                              <p:pRg st="2" end="2"/>
+                                            </p:txEl>
+                                          </p:spTgt>
+                                        </p:tgtEl>
+                                      </p:cBhvr>
+                                    </p:animEffect>
                                   </p:childTnLst>
                                 </p:cTn>
                               </p:par>

</xml_diff>